<commit_message>
added the pads after sessions
</commit_message>
<xml_diff>
--- a/instructors/09_Working-with-files_v3.0.pptx
+++ b/instructors/09_Working-with-files_v3.0.pptx
@@ -222,7 +222,7 @@
           <a:p>
             <a:fld id="{585C48AE-4A1E-9A43-835F-510354165F99}" type="datetimeFigureOut">
               <a:rPr lang="en-GB" smtClean="0"/>
-              <a:t>17/01/2023</a:t>
+              <a:t>21/01/2025</a:t>
             </a:fld>
             <a:endParaRPr lang="en-GB"/>
           </a:p>
@@ -1825,7 +1825,7 @@
               <a:tabLst/>
               <a:defRPr/>
             </a:pPr>
-            <a:endParaRPr lang="en-GB" b="0" i="0">
+            <a:endParaRPr lang="en-GB" b="0" i="0" dirty="0">
               <a:solidFill>
                 <a:srgbClr val="333333"/>
               </a:solidFill>
@@ -1852,24 +1852,14 @@
               <a:defRPr/>
             </a:pPr>
             <a:r>
-              <a:rPr lang="en-GB" b="0" i="0">
+              <a:rPr lang="en-GB" b="0" i="0" dirty="0">
                 <a:solidFill>
                   <a:srgbClr val="333333"/>
                 </a:solidFill>
                 <a:effectLst/>
                 <a:latin typeface="Ubuntu"/>
               </a:rPr>
-              <a:t>d</a:t>
-            </a:r>
-            <a:r>
-              <a:rPr lang="en-GB" b="0" i="0" dirty="0">
-                <a:solidFill>
-                  <a:srgbClr val="333333"/>
-                </a:solidFill>
-                <a:effectLst/>
-                <a:latin typeface="Ubuntu"/>
-              </a:rPr>
-              <a:t>) is useful when we are interested in outcomes of drug treatments</a:t>
+              <a:t>d) is useful when we are interested in outcomes of drug treatments</a:t>
             </a:r>
           </a:p>
           <a:p>
@@ -2353,7 +2343,7 @@
           <a:p>
             <a:fld id="{5913FB77-D8DB-4AB9-8EA5-EE8C3B57A5E1}" type="datetimeFigureOut">
               <a:rPr lang="en-GB" smtClean="0"/>
-              <a:t>17/01/2023</a:t>
+              <a:t>21/01/2025</a:t>
             </a:fld>
             <a:endParaRPr lang="en-GB"/>
           </a:p>
@@ -2600,7 +2590,7 @@
           <a:p>
             <a:fld id="{5913FB77-D8DB-4AB9-8EA5-EE8C3B57A5E1}" type="datetimeFigureOut">
               <a:rPr lang="en-GB" smtClean="0"/>
-              <a:t>17/01/2023</a:t>
+              <a:t>21/01/2025</a:t>
             </a:fld>
             <a:endParaRPr lang="en-GB"/>
           </a:p>
@@ -2810,7 +2800,7 @@
           <a:p>
             <a:fld id="{5913FB77-D8DB-4AB9-8EA5-EE8C3B57A5E1}" type="datetimeFigureOut">
               <a:rPr lang="en-GB" smtClean="0"/>
-              <a:t>17/01/2023</a:t>
+              <a:t>21/01/2025</a:t>
             </a:fld>
             <a:endParaRPr lang="en-GB"/>
           </a:p>
@@ -3010,7 +3000,7 @@
           <a:p>
             <a:fld id="{5913FB77-D8DB-4AB9-8EA5-EE8C3B57A5E1}" type="datetimeFigureOut">
               <a:rPr lang="en-GB" smtClean="0"/>
-              <a:t>17/01/2023</a:t>
+              <a:t>21/01/2025</a:t>
             </a:fld>
             <a:endParaRPr lang="en-GB"/>
           </a:p>
@@ -3286,7 +3276,7 @@
           <a:p>
             <a:fld id="{5913FB77-D8DB-4AB9-8EA5-EE8C3B57A5E1}" type="datetimeFigureOut">
               <a:rPr lang="en-GB" smtClean="0"/>
-              <a:t>17/01/2023</a:t>
+              <a:t>21/01/2025</a:t>
             </a:fld>
             <a:endParaRPr lang="en-GB"/>
           </a:p>
@@ -3554,7 +3544,7 @@
           <a:p>
             <a:fld id="{5913FB77-D8DB-4AB9-8EA5-EE8C3B57A5E1}" type="datetimeFigureOut">
               <a:rPr lang="en-GB" smtClean="0"/>
-              <a:t>17/01/2023</a:t>
+              <a:t>21/01/2025</a:t>
             </a:fld>
             <a:endParaRPr lang="en-GB"/>
           </a:p>
@@ -3969,7 +3959,7 @@
           <a:p>
             <a:fld id="{5913FB77-D8DB-4AB9-8EA5-EE8C3B57A5E1}" type="datetimeFigureOut">
               <a:rPr lang="en-GB" smtClean="0"/>
-              <a:t>17/01/2023</a:t>
+              <a:t>21/01/2025</a:t>
             </a:fld>
             <a:endParaRPr lang="en-GB"/>
           </a:p>
@@ -4111,7 +4101,7 @@
           <a:p>
             <a:fld id="{5913FB77-D8DB-4AB9-8EA5-EE8C3B57A5E1}" type="datetimeFigureOut">
               <a:rPr lang="en-GB" smtClean="0"/>
-              <a:t>17/01/2023</a:t>
+              <a:t>21/01/2025</a:t>
             </a:fld>
             <a:endParaRPr lang="en-GB"/>
           </a:p>
@@ -4224,7 +4214,7 @@
           <a:p>
             <a:fld id="{5913FB77-D8DB-4AB9-8EA5-EE8C3B57A5E1}" type="datetimeFigureOut">
               <a:rPr lang="en-GB" smtClean="0"/>
-              <a:t>17/01/2023</a:t>
+              <a:t>21/01/2025</a:t>
             </a:fld>
             <a:endParaRPr lang="en-GB"/>
           </a:p>
@@ -4537,7 +4527,7 @@
           <a:p>
             <a:fld id="{5913FB77-D8DB-4AB9-8EA5-EE8C3B57A5E1}" type="datetimeFigureOut">
               <a:rPr lang="en-GB" smtClean="0"/>
-              <a:t>17/01/2023</a:t>
+              <a:t>21/01/2025</a:t>
             </a:fld>
             <a:endParaRPr lang="en-GB"/>
           </a:p>
@@ -4826,7 +4816,7 @@
           <a:p>
             <a:fld id="{5913FB77-D8DB-4AB9-8EA5-EE8C3B57A5E1}" type="datetimeFigureOut">
               <a:rPr lang="en-GB" smtClean="0"/>
-              <a:t>17/01/2023</a:t>
+              <a:t>21/01/2025</a:t>
             </a:fld>
             <a:endParaRPr lang="en-GB"/>
           </a:p>
@@ -5068,7 +5058,7 @@
             <a:fld id="{5913FB77-D8DB-4AB9-8EA5-EE8C3B57A5E1}" type="datetimeFigureOut">
               <a:rPr lang="en-GB" smtClean="0"/>
               <a:pPr/>
-              <a:t>17/01/2023</a:t>
+              <a:t>21/01/2025</a:t>
             </a:fld>
             <a:endParaRPr lang="en-GB"/>
           </a:p>
@@ -6166,14 +6156,6 @@
               </a:rPr>
               <a:t> special characters </a:t>
             </a:r>
-            <a:r>
-              <a:rPr lang="pl-PL" sz="2800" dirty="0">
-                <a:solidFill>
-                  <a:srgbClr val="0070C0"/>
-                </a:solidFill>
-              </a:rPr>
-              <a:t/>
-            </a:r>
             <a:br>
               <a:rPr lang="pl-PL" sz="2800" dirty="0">
                 <a:solidFill>
@@ -6472,14 +6454,6 @@
               </a:rPr>
               <a:t>elements</a:t>
             </a:r>
-            <a:r>
-              <a:rPr lang="pl-PL" sz="2800" dirty="0">
-                <a:solidFill>
-                  <a:srgbClr val="0070C0"/>
-                </a:solidFill>
-              </a:rPr>
-              <a:t/>
-            </a:r>
             <a:br>
               <a:rPr lang="pl-PL" sz="2800" dirty="0">
                 <a:solidFill>
@@ -6577,14 +6551,6 @@
               </a:rPr>
               <a:t> deep paths with long names </a:t>
             </a:r>
-            <a:r>
-              <a:rPr lang="pl-PL" sz="2800" dirty="0">
-                <a:solidFill>
-                  <a:srgbClr val="0070C0"/>
-                </a:solidFill>
-              </a:rPr>
-              <a:t/>
-            </a:r>
             <a:br>
               <a:rPr lang="pl-PL" sz="2800" dirty="0">
                 <a:solidFill>
@@ -6599,14 +6565,6 @@
                 </a:solidFill>
               </a:rPr>
               <a:t>(i.e. deeply nested folders with long names) </a:t>
-            </a:r>
-            <a:r>
-              <a:rPr lang="pl-PL" sz="2800" dirty="0">
-                <a:solidFill>
-                  <a:srgbClr val="0070C0"/>
-                </a:solidFill>
-              </a:rPr>
-              <a:t/>
             </a:r>
             <a:br>
               <a:rPr lang="pl-PL" sz="2800" dirty="0">
@@ -7886,14 +7844,6 @@
             </a:r>
           </a:p>
           <a:p>
-            <a:r>
-              <a:rPr lang="en-GB" sz="2800" dirty="0">
-                <a:solidFill>
-                  <a:srgbClr val="0070C0"/>
-                </a:solidFill>
-              </a:rPr>
-              <a:t/>
-            </a:r>
             <a:br>
               <a:rPr lang="en-GB" sz="2800" dirty="0">
                 <a:solidFill>
@@ -8658,14 +8608,6 @@
               </a:rPr>
               <a:t>If you change the strategy document it in PROJECT_STRUCTURE </a:t>
             </a:r>
-            <a:r>
-              <a:rPr lang="pl-PL" sz="2800" dirty="0">
-                <a:solidFill>
-                  <a:srgbClr val="0070C0"/>
-                </a:solidFill>
-              </a:rPr>
-              <a:t/>
-            </a:r>
             <a:br>
               <a:rPr lang="pl-PL" sz="2800" dirty="0">
                 <a:solidFill>
@@ -8774,7 +8716,7 @@
                   <a:srgbClr val="0070C0"/>
                 </a:solidFill>
               </a:rPr>
-              <a:t>Bulk renaming of files can be done with the software such as Ant </a:t>
+              <a:t>Bulk renaming of files can be done using software such as Ant </a:t>
             </a:r>
             <a:r>
               <a:rPr lang="en-GB" sz="2800" dirty="0" err="1">
@@ -8806,7 +8748,7 @@
                   <a:srgbClr val="0070C0"/>
                 </a:solidFill>
               </a:rPr>
-              <a:t> or Rename4Mac.</a:t>
+              <a:t>, Bulk Rename, or Rename4Mac.</a:t>
             </a:r>
           </a:p>
         </p:txBody>
@@ -8955,7 +8897,7 @@
               </a:lnSpc>
             </a:pPr>
             <a:r>
-              <a:rPr lang="pl-PL" sz="4000" dirty="0" smtClean="0">
+              <a:rPr lang="pl-PL" sz="4000" dirty="0">
                 <a:solidFill>
                   <a:srgbClr val="0070C0"/>
                 </a:solidFill>
@@ -9033,30 +8975,14 @@
               <a:buChar char="•"/>
             </a:pPr>
             <a:r>
-              <a:rPr lang="en-GB" sz="2800" dirty="0" smtClean="0">
-                <a:solidFill>
-                  <a:srgbClr val="0070C0"/>
-                </a:solidFill>
-              </a:rPr>
-              <a:t>A </a:t>
-            </a:r>
-            <a:r>
               <a:rPr lang="en-GB" sz="2800" dirty="0">
                 <a:solidFill>
                   <a:srgbClr val="0070C0"/>
                 </a:solidFill>
               </a:rPr>
-              <a:t>good file name suggests the file </a:t>
-            </a:r>
-            <a:r>
-              <a:rPr lang="en-GB" sz="2800" dirty="0" smtClean="0">
-                <a:solidFill>
-                  <a:srgbClr val="0070C0"/>
-                </a:solidFill>
-              </a:rPr>
-              <a:t>content</a:t>
-            </a:r>
-            <a:endParaRPr lang="pl-PL" sz="2800" dirty="0" smtClean="0">
+              <a:t>A good file name suggests the file content</a:t>
+            </a:r>
+            <a:endParaRPr lang="pl-PL" sz="2800" dirty="0">
               <a:solidFill>
                 <a:srgbClr val="0070C0"/>
               </a:solidFill>
@@ -9079,30 +9005,14 @@
               <a:buChar char="•"/>
             </a:pPr>
             <a:r>
-              <a:rPr lang="en-GB" sz="2800" dirty="0" smtClean="0">
-                <a:solidFill>
-                  <a:srgbClr val="0070C0"/>
-                </a:solidFill>
-              </a:rPr>
-              <a:t>Good </a:t>
-            </a:r>
-            <a:r>
               <a:rPr lang="en-GB" sz="2800" dirty="0">
                 <a:solidFill>
                   <a:srgbClr val="0070C0"/>
                 </a:solidFill>
               </a:rPr>
-              <a:t>project organization saves you </a:t>
-            </a:r>
-            <a:r>
-              <a:rPr lang="en-GB" sz="2800" dirty="0" smtClean="0">
-                <a:solidFill>
-                  <a:srgbClr val="0070C0"/>
-                </a:solidFill>
-              </a:rPr>
-              <a:t>time</a:t>
-            </a:r>
-            <a:endParaRPr lang="pl-PL" sz="2800" dirty="0" smtClean="0">
+              <a:t>Good project organization saves you time</a:t>
+            </a:r>
+            <a:endParaRPr lang="pl-PL" sz="2800" dirty="0">
               <a:solidFill>
                 <a:srgbClr val="0070C0"/>
               </a:solidFill>
@@ -9125,34 +9035,13 @@
               <a:buChar char="•"/>
             </a:pPr>
             <a:r>
-              <a:rPr lang="en-GB" sz="2800" dirty="0" smtClean="0">
-                <a:solidFill>
-                  <a:srgbClr val="0070C0"/>
-                </a:solidFill>
-              </a:rPr>
-              <a:t>Describe </a:t>
-            </a:r>
-            <a:r>
               <a:rPr lang="en-GB" sz="2800" dirty="0">
                 <a:solidFill>
                   <a:srgbClr val="0070C0"/>
                 </a:solidFill>
               </a:rPr>
-              <a:t>your files organization in PROJECT_STRUCTURE or README including naming </a:t>
-            </a:r>
-            <a:r>
-              <a:rPr lang="en-GB" sz="2800" dirty="0" smtClean="0">
-                <a:solidFill>
-                  <a:srgbClr val="0070C0"/>
-                </a:solidFill>
-              </a:rPr>
-              <a:t>convention</a:t>
-            </a:r>
-            <a:endParaRPr lang="en-GB" sz="2800" dirty="0">
-              <a:solidFill>
-                <a:srgbClr val="0070C0"/>
-              </a:solidFill>
-            </a:endParaRPr>
+              <a:t>Describe your files organization in PROJECT_STRUCTURE or README including naming convention</a:t>
+            </a:r>
           </a:p>
         </p:txBody>
       </p:sp>
@@ -9230,7 +9119,7 @@
           <a:lstStyle/>
           <a:p>
             <a:r>
-              <a:rPr lang="pl-PL" dirty="0" smtClean="0"/>
+              <a:rPr lang="pl-PL" dirty="0"/>
               <a:t>Key points</a:t>
             </a:r>
             <a:endParaRPr lang="en-GB" dirty="0"/>
@@ -9300,7 +9189,7 @@
               <a:buChar char="•"/>
             </a:pPr>
             <a:r>
-              <a:rPr lang="pl-PL" sz="2800" dirty="0" smtClean="0">
+              <a:rPr lang="pl-PL" sz="2800" dirty="0">
                 <a:solidFill>
                   <a:srgbClr val="0070C0"/>
                 </a:solidFill>
@@ -9308,20 +9197,12 @@
               <a:t>Find</a:t>
             </a:r>
             <a:r>
-              <a:rPr lang="en-GB" sz="2800" dirty="0" smtClean="0">
-                <a:solidFill>
-                  <a:srgbClr val="0070C0"/>
-                </a:solidFill>
-              </a:rPr>
-              <a:t> </a:t>
-            </a:r>
-            <a:r>
               <a:rPr lang="en-GB" sz="2800" dirty="0">
                 <a:solidFill>
                   <a:srgbClr val="0070C0"/>
                 </a:solidFill>
               </a:rPr>
-              <a:t>files</a:t>
+              <a:t> files</a:t>
             </a:r>
             <a:r>
               <a:rPr lang="pl-PL" sz="2800" dirty="0">
@@ -10457,14 +10338,6 @@
                 </a:solidFill>
               </a:rPr>
             </a:br>
-            <a:r>
-              <a:rPr lang="pl-PL" sz="2800" dirty="0">
-                <a:solidFill>
-                  <a:srgbClr val="0070C0"/>
-                </a:solidFill>
-              </a:rPr>
-              <a:t/>
-            </a:r>
             <a:br>
               <a:rPr lang="pl-PL" sz="2800" dirty="0">
                 <a:solidFill>
@@ -10495,14 +10368,6 @@
                 </a:solidFill>
               </a:rPr>
             </a:br>
-            <a:r>
-              <a:rPr lang="pl-PL" sz="2400" dirty="0">
-                <a:solidFill>
-                  <a:srgbClr val="0070C0"/>
-                </a:solidFill>
-              </a:rPr>
-              <a:t/>
-            </a:r>
             <a:br>
               <a:rPr lang="pl-PL" sz="2400" dirty="0">
                 <a:solidFill>
@@ -10571,14 +10436,6 @@
                 </a:solidFill>
               </a:rPr>
             </a:br>
-            <a:r>
-              <a:rPr lang="pl-PL" sz="2800" dirty="0">
-                <a:solidFill>
-                  <a:srgbClr val="0070C0"/>
-                </a:solidFill>
-              </a:rPr>
-              <a:t/>
-            </a:r>
             <a:br>
               <a:rPr lang="pl-PL" sz="2800" dirty="0">
                 <a:solidFill>
@@ -10891,14 +10748,6 @@
                 </a:solidFill>
               </a:rPr>
             </a:br>
-            <a:r>
-              <a:rPr lang="pl-PL" sz="2800" dirty="0">
-                <a:solidFill>
-                  <a:srgbClr val="0070C0"/>
-                </a:solidFill>
-              </a:rPr>
-              <a:t/>
-            </a:r>
             <a:br>
               <a:rPr lang="pl-PL" sz="2800" dirty="0">
                 <a:solidFill>

</xml_diff>